<commit_message>
Mediator notifica a las aeronaves; UML y PPTX alineados con el código
</commit_message>
<xml_diff>
--- a/documentacion/PDS_Actividad03_Grupo02.pptx
+++ b/documentacion/PDS_Actividad03_Grupo02.pptx
@@ -2879,7 +2879,7 @@
                 <a:ea typeface="Calibri" panose="020F0502020204030204" pitchFamily="34" charset="0"/>
                 <a:cs typeface="Times New Roman" panose="02020603050405020304" pitchFamily="18" charset="0"/>
               </a:rPr>
-              <a:t>Elaborado por (Grupo 03):</a:t>
+              <a:t>Elaborado por (Grupo 02):</a:t>
             </a:r>
             <a:endParaRPr lang="en-US" sz="2400" dirty="0">
               <a:effectLst/>
@@ -5383,7 +5383,7 @@
                   </a:schemeClr>
                 </a:solidFill>
               </a:rPr>
-              <a:t>"En un sistema de gestión de tráfico aéreo, múltiples aeronaves necesitan coordinar sus operaciones de despegue, aterrizaje y reporte de posición de forma simultánea. Si cada aeronave estableciera comunicación directa y bilateral con las demás, se generaría una red caótica de dependencias cruzadas (muchos a muchos), provocando un alto acoplamiento, rigidez estructural y una alta complejidad para gestionar el estado compartido de la pista. Se requiere un diseño que centralice la lógica de coordinación y permita que las aeronaves interactúen de manera completamente desacoplada."</a:t>
+              <a:t>"Un control remoto debe encender y apagar dispositivos, como una luz. Si el control invocara directamente los métodos del dispositivo (presionarBotonEncender(), presionarBotonApagar()), quedaría acoplado a un dispositivo y a acciones concretas: cada nueva acción o dispositivo obligaría a modificar el control y a añadir métodos o condicionales, y no se podría reasignar la acción de un botón en tiempo de ejecución. Se requiere un diseño que encapsule cada solicitud como un objeto, de modo que el control solo invoque una operación genérica sin conocer al dispositivo ni la acción concreta."</a:t>
             </a:r>
             <a:endParaRPr lang="en-US" dirty="0">
               <a:solidFill>
@@ -5748,7 +5748,7 @@
                   <a:srgbClr val="272727"/>
                 </a:solidFill>
               </a:rPr>
-              <a:t>Ejemplo: Comando</a:t>
+              <a:t>Ejemplo: IComando</a:t>
             </a:r>
             <a:endParaRPr lang="en-US" sz="1250" dirty="0"/>
           </a:p>
@@ -6392,7 +6392,7 @@
                   <a:srgbClr val="272727"/>
                 </a:solidFill>
               </a:rPr>
-              <a:t>Ejemplo: AplicacionCommand</a:t>
+              <a:t>Ejemplo: MainCommandControlLuces</a:t>
             </a:r>
             <a:endParaRPr lang="en-US" sz="1250" dirty="0"/>
           </a:p>
@@ -6709,7 +6709,7 @@
                   </a:schemeClr>
                 </a:solidFill>
               </a:rPr>
-              <a:t>«interface» Comando</a:t>
+              <a:t>«interface» IComando</a:t>
             </a:r>
             <a:endParaRPr lang="en-US" sz="1600" dirty="0">
               <a:solidFill>
@@ -7509,7 +7509,7 @@
                   </a:schemeClr>
                 </a:solidFill>
               </a:rPr>
-              <a:t>AplicacionCommand</a:t>
+              <a:t>MainCommandControlLuces</a:t>
             </a:r>
             <a:endParaRPr lang="en-US" sz="1600" dirty="0">
               <a:solidFill>
@@ -7720,8 +7720,8 @@
         </p:blipFill>
         <p:spPr>
           <a:xfrm>
-            <a:off x="298408" y="948602"/>
-            <a:ext cx="4597683" cy="5334308"/>
+            <a:off x="298408" y="1000000"/>
+            <a:ext cx="3600000" cy="3686573"/>
           </a:xfrm>
           <a:prstGeom prst="rect">
             <a:avLst/>
@@ -7744,15 +7744,14 @@
         </p:nvPicPr>
         <p:blipFill>
           <a:blip r:embed="rId4"/>
-          <a:srcRect l="8208" t="4037" r="5130" b="3428"/>
           <a:stretch>
             <a:fillRect/>
           </a:stretch>
         </p:blipFill>
         <p:spPr>
           <a:xfrm>
-            <a:off x="6589467" y="745237"/>
-            <a:ext cx="5023413" cy="5741038"/>
+            <a:off x="4100000" y="850000"/>
+            <a:ext cx="7900000" cy="5621154"/>
           </a:xfrm>
           <a:prstGeom prst="rect">
             <a:avLst/>
@@ -8075,7 +8074,7 @@
                   </a:schemeClr>
                 </a:solidFill>
               </a:rPr>
-              <a:t> Introducir una interfaz abstracta común (Comando) que exponga un único método de ejecución estándar (ejecutar()), manteniendo una referencia directa al receptor (Luz) dentro de los comandos concretos (</a:t>
+              <a:t> Introducir una interfaz abstracta común (IComando) que exponga un único método de ejecución estándar (ejecutar()), manteniendo una referencia directa al receptor (Luz) dentro de los comandos concretos (</a:t>
             </a:r>
             <a:r>
               <a:rPr lang="es-MX" sz="1500" dirty="0" err="1">
@@ -14898,7 +14897,7 @@
                   <a:srgbClr val="272727"/>
                 </a:solidFill>
               </a:rPr>
-              <a:t>→ TorreControl</a:t>
+              <a:t>→ ITorreControl</a:t>
             </a:r>
             <a:endParaRPr lang="en-US" sz="1400" dirty="0"/>
           </a:p>
@@ -15282,7 +15281,7 @@
                   </a:schemeClr>
                 </a:solidFill>
               </a:rPr>
-              <a:t>"En un sistema de gestión de tráfico aéreo, múltiples aeronaves necesitan coordinar sus operaciones de despegue, aterrizaje y reporte de posición de forma simultánea. Si cada aeronave estableciera comunicación directa y bilateral con las demás, se generaría una red caótica de dependencias cruzadas (muchos a muchos), provocando un alto acoplamiento, rigidez estructural y una alta complejidad para gestionar el estado compartido de la pista. Se requiere un diseño que centralice la lógica de coordinación y permita que las aeronaves interactúen de manera completamente desacoplada."</a:t>
+              <a:t>"En un sistema de gestión de tráfico aéreo, múltiples aeronaves necesitan coordinar el aterrizaje sobre una misma pista. Si cada aeronave estableciera comunicación directa y bilateral con las demás, se generaría una red caótica de dependencias cruzadas (muchos a muchos), provocando un alto acoplamiento, rigidez estructural y una alta complejidad para gestionar el estado compartido de la pista y el orden de espera. Se requiere un diseño que centralice la coordinación en una torre de control que autorice y notifique a las aeronaves, permitiendo que estas interactúen de manera completamente desacoplada."</a:t>
             </a:r>
             <a:endParaRPr lang="en-US" dirty="0">
               <a:solidFill>
@@ -15559,7 +15558,7 @@
             </a:pPr>
             <a:r>
               <a:rPr lang="en-US" sz="1600" b="1" dirty="0"/>
-              <a:t>«interface» TorreControl</a:t>
+              <a:t>«interface» ITorreControl</a:t>
             </a:r>
             <a:endParaRPr lang="en-US" sz="1600" dirty="0"/>
           </a:p>
@@ -15593,7 +15592,7 @@
             </a:pPr>
             <a:r>
               <a:rPr lang="en-US" sz="1050" dirty="0"/>
-              <a:t>+ solicitarAterrizaje()  + liberarPista()</a:t>
+              <a:t>+ registrarAeronave()  + solicitarAterrizaje()  + liberarPista()</a:t>
             </a:r>
           </a:p>
         </p:txBody>
@@ -15691,7 +15690,7 @@
             </a:pPr>
             <a:r>
               <a:rPr lang="en-US" sz="1050" dirty="0"/>
-              <a:t>- pistaOcupada  - avionEnPista</a:t>
+              <a:t>- listaAeronaves  - colaEspera  - aeronaveEnPista</a:t>
             </a:r>
           </a:p>
         </p:txBody>
@@ -15821,7 +15820,7 @@
             </a:pPr>
             <a:r>
               <a:rPr lang="en-US" sz="1050" dirty="0"/>
-              <a:t># identificador  # torreControl</a:t>
+              <a:t># identificador  # torreControl  # autorizada</a:t>
             </a:r>
           </a:p>
         </p:txBody>
@@ -16195,7 +16194,7 @@
                   <a:srgbClr val="272727"/>
                 </a:solidFill>
               </a:rPr>
-              <a:t>• Los aviones dependen de la abstracción TorreControl.</a:t>
+              <a:t>• Los aviones dependen de la abstracción ITorreControl.</a:t>
             </a:r>
             <a:endParaRPr lang="en-US" sz="1250" dirty="0"/>
           </a:p>
@@ -16215,7 +16214,7 @@
                   <a:srgbClr val="272727"/>
                 </a:solidFill>
               </a:rPr>
-              <a:t>• La torre concreta administra el estado compartido de la pista.</a:t>
+              <a:t>• La torre concreta administra la pista y la cola de espera, y notifica a las aeronaves.</a:t>
             </a:r>
             <a:endParaRPr lang="en-US" sz="1250" dirty="0"/>
           </a:p>
@@ -16354,8 +16353,8 @@
         </p:blipFill>
         <p:spPr>
           <a:xfrm>
-            <a:off x="146612" y="658052"/>
-            <a:ext cx="5559707" cy="5522829"/>
+            <a:off x="146612" y="1000000"/>
+            <a:ext cx="3900000" cy="3316659"/>
           </a:xfrm>
           <a:prstGeom prst="rect">
             <a:avLst/>
@@ -16384,15 +16383,14 @@
         </p:nvPicPr>
         <p:blipFill>
           <a:blip r:embed="rId3"/>
-          <a:srcRect l="4148"/>
           <a:stretch>
             <a:fillRect/>
           </a:stretch>
         </p:blipFill>
         <p:spPr>
           <a:xfrm>
-            <a:off x="6319777" y="611752"/>
-            <a:ext cx="5559707" cy="5696449"/>
+            <a:off x="4200000" y="1000000"/>
+            <a:ext cx="7800000" cy="4524000"/>
           </a:xfrm>
           <a:prstGeom prst="rect">
             <a:avLst/>
@@ -16499,8 +16497,8 @@
         </p:blipFill>
         <p:spPr>
           <a:xfrm>
-            <a:off x="922306" y="996060"/>
-            <a:ext cx="10347388" cy="4941753"/>
+            <a:off x="1325000" y="950000"/>
+            <a:ext cx="9542000" cy="5500000"/>
           </a:xfrm>
           <a:prstGeom prst="rect">
             <a:avLst/>

</xml_diff>

<commit_message>
Presentación alineada con los diagramas
Diapositivas 5 y 7 incluyen el cliente de Mediator; 8 y 16 usan la
exportación actual del .drawio.

Co-Authored-By: Claude Opus 5.5 <noreply@anthropic.com>
</commit_message>
<xml_diff>
--- a/documentacion/PDS_Actividad03_Grupo02.pptx
+++ b/documentacion/PDS_Actividad03_Grupo02.pptx
@@ -7502,7 +7502,7 @@
               <a:buNone/>
             </a:pPr>
             <a:r>
-              <a:rPr lang="en-US" sz="1600" b="1" dirty="0">
+              <a:rPr lang="en-US" sz="1400" b="1" dirty="0">
                 <a:solidFill>
                   <a:schemeClr val="accent1">
                     <a:lumMod val="50000"/>
@@ -7750,8 +7750,8 @@
         </p:blipFill>
         <p:spPr>
           <a:xfrm>
-            <a:off x="4100000" y="850000"/>
-            <a:ext cx="7900000" cy="5621154"/>
+            <a:off x="4100000" y="935963"/>
+            <a:ext cx="7900000" cy="5449227"/>
           </a:xfrm>
           <a:prstGeom prst="rect">
             <a:avLst/>
@@ -15049,6 +15049,78 @@
       </p:sp>
       <p:sp>
         <p:nvSpPr>
+          <p:cNvPr id="31" name="Text 27"/>
+          <p:cNvSpPr/>
+          <p:nvPr/>
+        </p:nvSpPr>
+        <p:spPr>
+          <a:xfrm>
+            <a:off x="731520" y="5623560"/>
+            <a:ext cx="1828800" cy="274320"/>
+          </a:xfrm>
+          <a:prstGeom prst="rect">
+            <a:avLst/>
+          </a:prstGeom>
+          <a:noFill/>
+          <a:ln/>
+        </p:spPr>
+        <p:txBody>
+          <a:bodyPr wrap="square" lIns="0" tIns="0" rIns="0" bIns="0" rtlCol="0" anchor="ctr"/>
+          <a:lstStyle/>
+          <a:p>
+            <a:pPr marL="0" indent="0">
+              <a:buNone/>
+            </a:pPr>
+            <a:r>
+              <a:rPr lang="en-US" sz="1400" b="1" dirty="0">
+                <a:solidFill>
+                  <a:srgbClr val="4472C4"/>
+                </a:solidFill>
+              </a:rPr>
+              <a:t>Client</a:t>
+            </a:r>
+            <a:endParaRPr lang="en-US" sz="1400" dirty="0"/>
+          </a:p>
+        </p:txBody>
+      </p:sp>
+      <p:sp>
+        <p:nvSpPr>
+          <p:cNvPr id="32" name="Text 28"/>
+          <p:cNvSpPr/>
+          <p:nvPr/>
+        </p:nvSpPr>
+        <p:spPr>
+          <a:xfrm>
+            <a:off x="2651760" y="5623560"/>
+            <a:ext cx="3200400" cy="274320"/>
+          </a:xfrm>
+          <a:prstGeom prst="rect">
+            <a:avLst/>
+          </a:prstGeom>
+          <a:noFill/>
+          <a:ln/>
+        </p:spPr>
+        <p:txBody>
+          <a:bodyPr wrap="square" lIns="0" tIns="0" rIns="0" bIns="0" rtlCol="0" anchor="ctr"/>
+          <a:lstStyle/>
+          <a:p>
+            <a:pPr marL="0" indent="0">
+              <a:buNone/>
+            </a:pPr>
+            <a:r>
+              <a:rPr lang="en-US" sz="1400" dirty="0">
+                <a:solidFill>
+                  <a:srgbClr val="272727"/>
+                </a:solidFill>
+              </a:rPr>
+              <a:t>→ MainMediatorTorreControl</a:t>
+            </a:r>
+            <a:endParaRPr lang="en-US" sz="1400" dirty="0"/>
+          </a:p>
+        </p:txBody>
+      </p:sp>
+      <p:sp>
+        <p:nvSpPr>
           <p:cNvPr id="28" name="Text 25"/>
           <p:cNvSpPr/>
           <p:nvPr/>
@@ -16257,6 +16329,212 @@
               <a:t>• No existe una asociación directa entre aviones.</a:t>
             </a:r>
             <a:endParaRPr lang="en-US" sz="1250" dirty="0"/>
+          </a:p>
+          <a:p>
+            <a:pPr marL="0" indent="0">
+              <a:buNone/>
+            </a:pPr>
+            <a:endParaRPr lang="en-US" sz="1250" dirty="0"/>
+          </a:p>
+          <a:p>
+            <a:pPr marL="0" indent="0">
+              <a:buNone/>
+            </a:pPr>
+            <a:r>
+              <a:rPr lang="en-US" sz="1250" dirty="0">
+                <a:solidFill>
+                  <a:srgbClr val="272727"/>
+                </a:solidFill>
+              </a:rPr>
+              <a:t>• MainMediatorTorreControl crea la torre y las aeronaves.</a:t>
+            </a:r>
+            <a:endParaRPr lang="en-US" sz="1250" dirty="0"/>
+          </a:p>
+        </p:txBody>
+      </p:sp>
+      <p:sp>
+        <p:nvSpPr>
+          <p:cNvPr id="27" name="Shape 21"/>
+          <p:cNvSpPr/>
+          <p:nvPr/>
+        </p:nvSpPr>
+        <p:spPr>
+          <a:xfrm>
+            <a:off x="4617720" y="4663440"/>
+            <a:ext cx="2926080" cy="868680"/>
+          </a:xfrm>
+          <a:prstGeom prst="roundRect">
+            <a:avLst>
+              <a:gd name="adj" fmla="val 7778"/>
+            </a:avLst>
+          </a:prstGeom>
+          <a:noFill/>
+          <a:ln w="12700">
+            <a:solidFill>
+              <a:srgbClr val="954F72"/>
+            </a:solidFill>
+            <a:prstDash val="solid"/>
+          </a:ln>
+          <a:effectLst/>
+        </p:spPr>
+        <p:txBody>
+          <a:bodyPr/>
+          <a:lstStyle/>
+          <a:p>
+            <a:endParaRPr lang="en-US">
+              <a:solidFill>
+                <a:schemeClr val="accent1">
+                  <a:lumMod val="50000"/>
+                </a:schemeClr>
+              </a:solidFill>
+            </a:endParaRPr>
+          </a:p>
+        </p:txBody>
+      </p:sp>
+      <p:sp>
+        <p:nvSpPr>
+          <p:cNvPr id="28" name="Text 23"/>
+          <p:cNvSpPr/>
+          <p:nvPr/>
+        </p:nvSpPr>
+        <p:spPr>
+          <a:xfrm>
+            <a:off x="4727448" y="4828032"/>
+            <a:ext cx="2706624" cy="237744"/>
+          </a:xfrm>
+          <a:prstGeom prst="rect">
+            <a:avLst/>
+          </a:prstGeom>
+          <a:noFill/>
+          <a:ln/>
+        </p:spPr>
+        <p:txBody>
+          <a:bodyPr wrap="square" lIns="0" tIns="0" rIns="0" bIns="0" rtlCol="0" anchor="ctr"/>
+          <a:lstStyle/>
+          <a:p>
+            <a:pPr marL="0" indent="0" algn="ctr">
+              <a:buNone/>
+            </a:pPr>
+            <a:r>
+              <a:rPr lang="en-US" sz="1400" b="1" dirty="0">
+                <a:solidFill>
+                  <a:schemeClr val="accent1">
+                    <a:lumMod val="50000"/>
+                  </a:schemeClr>
+                </a:solidFill>
+              </a:rPr>
+              <a:t>MainMediatorTorreControl</a:t>
+            </a:r>
+            <a:endParaRPr lang="en-US" sz="1600" dirty="0">
+              <a:solidFill>
+                <a:schemeClr val="accent1">
+                  <a:lumMod val="50000"/>
+                </a:schemeClr>
+              </a:solidFill>
+            </a:endParaRPr>
+          </a:p>
+        </p:txBody>
+      </p:sp>
+      <p:sp>
+        <p:nvSpPr>
+          <p:cNvPr id="29" name="Text 24"/>
+          <p:cNvSpPr/>
+          <p:nvPr/>
+        </p:nvSpPr>
+        <p:spPr>
+          <a:xfrm>
+            <a:off x="4727448" y="5138928"/>
+            <a:ext cx="2706624" cy="329184"/>
+          </a:xfrm>
+          <a:prstGeom prst="rect">
+            <a:avLst/>
+          </a:prstGeom>
+          <a:noFill/>
+          <a:ln/>
+        </p:spPr>
+        <p:txBody>
+          <a:bodyPr wrap="square" lIns="0" tIns="0" rIns="0" bIns="0" rtlCol="0" anchor="ctr">
+            <a:normAutofit/>
+          </a:bodyPr>
+          <a:lstStyle/>
+          <a:p>
+            <a:pPr marL="0" indent="0" algn="ctr">
+              <a:buNone/>
+            </a:pPr>
+            <a:r>
+              <a:rPr lang="en-US" sz="1050" dirty="0">
+                <a:solidFill>
+                  <a:schemeClr val="accent1">
+                    <a:lumMod val="50000"/>
+                  </a:schemeClr>
+                </a:solidFill>
+              </a:rPr>
+              <a:t>+ main()</a:t>
+            </a:r>
+          </a:p>
+        </p:txBody>
+      </p:sp>
+      <p:sp>
+        <p:nvSpPr>
+          <p:cNvPr id="30" name="Shape 25"/>
+          <p:cNvSpPr/>
+          <p:nvPr/>
+        </p:nvSpPr>
+        <p:spPr>
+          <a:xfrm flipV="1">
+            <a:off x="6080760" y="3703320"/>
+            <a:ext cx="1" cy="960120"/>
+          </a:xfrm>
+          <a:prstGeom prst="line">
+            <a:avLst/>
+          </a:prstGeom>
+          <a:noFill/>
+          <a:ln w="25400">
+            <a:solidFill>
+              <a:srgbClr val="4472C4"/>
+            </a:solidFill>
+            <a:prstDash val="solid"/>
+            <a:headEnd type="none"/>
+            <a:tailEnd type="triangle"/>
+          </a:ln>
+        </p:spPr>
+        <p:txBody>
+          <a:bodyPr/>
+          <a:lstStyle/>
+          <a:p>
+            <a:endParaRPr lang="en-US"/>
+          </a:p>
+        </p:txBody>
+      </p:sp>
+      <p:sp>
+        <p:nvSpPr>
+          <p:cNvPr id="31" name="Shape 26"/>
+          <p:cNvSpPr/>
+          <p:nvPr/>
+        </p:nvSpPr>
+        <p:spPr>
+          <a:xfrm flipH="1">
+            <a:off x="3657600" y="5097780"/>
+            <a:ext cx="960120" cy="1"/>
+          </a:xfrm>
+          <a:prstGeom prst="line">
+            <a:avLst/>
+          </a:prstGeom>
+          <a:noFill/>
+          <a:ln w="25400">
+            <a:solidFill>
+              <a:srgbClr val="4472C4"/>
+            </a:solidFill>
+            <a:prstDash val="solid"/>
+            <a:headEnd type="none"/>
+            <a:tailEnd type="triangle"/>
+          </a:ln>
+        </p:spPr>
+        <p:txBody>
+          <a:bodyPr/>
+          <a:lstStyle/>
+          <a:p>
+            <a:endParaRPr lang="en-US"/>
           </a:p>
         </p:txBody>
       </p:sp>
@@ -16389,8 +16667,8 @@
         </p:blipFill>
         <p:spPr>
           <a:xfrm>
-            <a:off x="4200000" y="1000000"/>
-            <a:ext cx="7800000" cy="4524000"/>
+            <a:off x="4568815" y="1000000"/>
+            <a:ext cx="7062369" cy="5250000"/>
           </a:xfrm>
           <a:prstGeom prst="rect">
             <a:avLst/>

</xml_diff>

<commit_message>
Mejoras de Mediator y Command, pruebas e informe actualizado
- Mediator: AvionSanitario con prioridad en la torre, aviso de nuevas
  posiciones en la cola y registro de aeronaves desde el cliente.
- Command: deshacer con historial, Ventilador, MacroComando y control
  con varios botones reasignables.
- Pruebas unitarias con JUnit 5 (13 pruebas) y pom.xml para mvn test.
- Diagramas UML regenerados y alineados con el código.
- Informe (docx y pdf) y presentación actualizados.
</commit_message>
<xml_diff>
--- a/documentacion/PDS_Actividad03_Grupo02.pptx
+++ b/documentacion/PDS_Actividad03_Grupo02.pptx
@@ -18,6 +18,7 @@
     <p:sldId id="277" r:id="rId9"/>
     <p:sldId id="279" r:id="rId10"/>
     <p:sldId id="276" r:id="rId11"/>
+    <p:sldId id="282" r:id="rId29"/>
     <p:sldId id="262" r:id="rId12"/>
     <p:sldId id="263" r:id="rId13"/>
     <p:sldId id="264" r:id="rId14"/>
@@ -26,7 +27,9 @@
     <p:sldId id="275" r:id="rId17"/>
     <p:sldId id="280" r:id="rId18"/>
     <p:sldId id="278" r:id="rId19"/>
+    <p:sldId id="283" r:id="rId30"/>
     <p:sldId id="267" r:id="rId20"/>
+    <p:sldId id="284" r:id="rId31"/>
     <p:sldId id="268" r:id="rId21"/>
     <p:sldId id="272" r:id="rId22"/>
     <p:sldId id="273" r:id="rId23"/>
@@ -3577,7 +3580,7 @@
                   <a:schemeClr val="accent2"/>
                 </a:solidFill>
               </a:rPr>
-              <a:t>Uso crítico de inteligencia artificial</a:t>
+              <a:t>Uso crítico de IA (1/2): diseño inicial</a:t>
             </a:r>
             <a:endParaRPr lang="en-US" sz="2800" dirty="0">
               <a:solidFill>
@@ -5101,7 +5104,7 @@
             </a:pPr>
             <a:r>
               <a:rPr lang="en-US" sz="1600" b="1" dirty="0"/>
-              <a:t>Luz</a:t>
+              <a:t>Luz · Ventilador</a:t>
             </a:r>
             <a:endParaRPr lang="en-US" sz="1600" dirty="0"/>
           </a:p>
@@ -5337,7 +5340,7 @@
             </a:r>
             <a:r>
               <a:rPr lang="es-MX" sz="2800" dirty="0"/>
-              <a:t> (Control de Luces)</a:t>
+              <a:t> (Control domótico)</a:t>
             </a:r>
             <a:endParaRPr lang="en-US" sz="2800" dirty="0"/>
           </a:p>
@@ -5383,7 +5386,7 @@
                   </a:schemeClr>
                 </a:solidFill>
               </a:rPr>
-              <a:t>"Un control remoto debe encender y apagar dispositivos, como una luz. Si el control invocara directamente los métodos del dispositivo (presionarBotonEncender(), presionarBotonApagar()), quedaría acoplado a un dispositivo y a acciones concretas: cada nueva acción o dispositivo obligaría a modificar el control y a añadir métodos o condicionales, y no se podría reasignar la acción de un botón en tiempo de ejecución. Se requiere un diseño que encapsule cada solicitud como un objeto, de modo que el control solo invoque una operación genérica sin conocer al dispositivo ni la acción concreta."</a:t>
+              <a:t>"En una sala de reuniones, un control remoto programable de cuatro botones maneja la luz y un ventilador. Cada botón debe poder reasignarse en ejecución, se necesitan escenas como «Modo presentación» (apagar la luz y bajar el ventilador con un solo botón) y un botón Deshacer que revierta la última acción, incluida una escena completa. Si el control invocara directamente los métodos de cada dispositivo, quedaría acoplado a todos ellos: cada acción nueva obligaría a añadir métodos o condicionales, los botones quedarían fijos y no habría dónde registrar lo ejecutado para deshacerlo. Se requiere encapsular cada solicitud en un objeto que el control pueda ejecutar, registrar y revertir sin conocer su contenido."</a:t>
             </a:r>
             <a:endParaRPr lang="en-US" dirty="0">
               <a:solidFill>
@@ -5728,7 +5731,7 @@
                   <a:srgbClr val="272727"/>
                 </a:solidFill>
               </a:rPr>
-              <a:t>Declara ejecutar().</a:t>
+              <a:t>Declara ejecutar() y deshacer().</a:t>
             </a:r>
             <a:endParaRPr lang="en-US" sz="1250" dirty="0"/>
           </a:p>
@@ -5889,7 +5892,7 @@
                   <a:srgbClr val="272727"/>
                 </a:solidFill>
               </a:rPr>
-              <a:t>Vincula Receiver + acción.</a:t>
+              <a:t>Vincula Receiver + acción y sabe revertirla.</a:t>
             </a:r>
             <a:endParaRPr lang="en-US" sz="1250" dirty="0"/>
           </a:p>
@@ -5909,7 +5912,7 @@
                   <a:srgbClr val="272727"/>
                 </a:solidFill>
               </a:rPr>
-              <a:t>Ejemplo: EncenderLuzCommand</a:t>
+              <a:t>Ejemplo: EncenderLuzCommand, MacroComando</a:t>
             </a:r>
             <a:endParaRPr lang="en-US" sz="1250" dirty="0"/>
           </a:p>
@@ -6070,7 +6073,7 @@
                   <a:srgbClr val="272727"/>
                 </a:solidFill>
               </a:rPr>
-              <a:t>Ejemplo: Luz</a:t>
+              <a:t>Ejemplo: Luz, Ventilador</a:t>
             </a:r>
             <a:endParaRPr lang="en-US" sz="1250" dirty="0"/>
           </a:p>
@@ -6211,7 +6214,7 @@
                   <a:srgbClr val="272727"/>
                 </a:solidFill>
               </a:rPr>
-              <a:t>Solicita la ejecución.</a:t>
+              <a:t>Ejecuta por botón y guarda el historial.</a:t>
             </a:r>
             <a:endParaRPr lang="en-US" sz="1250" dirty="0"/>
           </a:p>
@@ -6632,7 +6635,7 @@
                   <a:srgbClr val="2F5496"/>
                 </a:solidFill>
               </a:rPr>
-              <a:t>UML del ejemplo: control de luces</a:t>
+              <a:t>UML del ejemplo: control domótico (vista simplificada)</a:t>
             </a:r>
             <a:endParaRPr lang="en-US" sz="2800" dirty="0"/>
           </a:p>
@@ -6755,7 +6758,7 @@
                   </a:schemeClr>
                 </a:solidFill>
               </a:rPr>
-              <a:t>+ ejecutar()</a:t>
+              <a:t>+ ejecutar()  + deshacer()</a:t>
             </a:r>
           </a:p>
         </p:txBody>
@@ -6877,7 +6880,7 @@
                   </a:schemeClr>
                 </a:solidFill>
               </a:rPr>
-              <a:t>- luz: Luz  + ejecutar()</a:t>
+              <a:t>- luz  - estadosPrevios  + ejecutar()  + deshacer()</a:t>
             </a:r>
           </a:p>
         </p:txBody>
@@ -7037,7 +7040,7 @@
                   </a:schemeClr>
                 </a:solidFill>
               </a:rPr>
-              <a:t>- luz: Luz  + ejecutar()</a:t>
+              <a:t>- luz  - estadosPrevios  + ejecutar()  + deshacer()</a:t>
             </a:r>
           </a:p>
         </p:txBody>
@@ -7197,7 +7200,7 @@
                   </a:schemeClr>
                 </a:solidFill>
               </a:rPr>
-              <a:t>+ encender()  + apagar()</a:t>
+              <a:t>+ encender()  + apagar()  + estaEncendida()</a:t>
             </a:r>
           </a:p>
         </p:txBody>
@@ -7395,7 +7398,7 @@
                   </a:schemeClr>
                 </a:solidFill>
               </a:rPr>
-              <a:t>- comando  + presionarBoton()</a:t>
+              <a:t>- ranuras  - historial  + presionarBoton(i)  + presionarDeshacer()</a:t>
             </a:r>
           </a:p>
         </p:txBody>
@@ -7640,6 +7643,39 @@
               <a:t>15</a:t>
             </a:fld>
             <a:endParaRPr lang="en-US"/>
+          </a:p>
+        </p:txBody>
+      </p:sp>
+      <p:sp>
+        <p:nvSpPr>
+          <p:cNvPr id="900" name="Nota vista simplificada"/>
+          <p:cNvSpPr txBox="1"/>
+          <p:nvPr/>
+        </p:nvSpPr>
+        <p:spPr>
+          <a:xfrm>
+            <a:off x="914400" y="5650000"/>
+            <a:ext cx="10241280" cy="420000"/>
+          </a:xfrm>
+          <a:prstGeom prst="rect">
+            <a:avLst/>
+          </a:prstGeom>
+          <a:noFill/>
+        </p:spPr>
+        <p:txBody>
+          <a:bodyPr wrap="square" lIns="0" tIns="0" rIns="0" bIns="0" anchor="ctr"/>
+          <a:lstStyle/>
+          <a:p>
+            <a:r>
+              <a:rPr lang="es-MX" sz="1200" dirty="0">
+                <a:solidFill>
+                  <a:schemeClr val="accent1">
+                    <a:lumMod val="75000"/>
+                  </a:schemeClr>
+                </a:solidFill>
+              </a:rPr>
+              <a:t>Vista simplificada: Ventilador, CambiarVelocidadVentiladorCommand y MacroComando se muestran en el UML completo de la siguiente diapositiva.</a:t>
+            </a:r>
           </a:p>
         </p:txBody>
       </p:sp>
@@ -7700,7 +7736,7 @@
       </p:pic>
       <p:pic>
         <p:nvPicPr>
-          <p:cNvPr id="6" name="Imagen 5" descr="Tabla&#10;&#10;El contenido generado por IA puede ser incorrecto.">
+          <p:cNvPr id="6" name="Imagen 5" descr="Diagrama original sin Command">
             <a:extLst>
               <a:ext uri="{FF2B5EF4-FFF2-40B4-BE49-F238E27FC236}">
                 <a16:creationId xmlns:a16="http://schemas.microsoft.com/office/drawing/2014/main" id="{474E1D30-F97E-633E-5967-8D94B1933D66}"/>
@@ -7720,8 +7756,8 @@
         </p:blipFill>
         <p:spPr>
           <a:xfrm>
-            <a:off x="298408" y="1000000"/>
-            <a:ext cx="3600000" cy="3686573"/>
+            <a:off x="250000" y="1100000"/>
+            <a:ext cx="3700000" cy="2830035"/>
           </a:xfrm>
           <a:prstGeom prst="rect">
             <a:avLst/>
@@ -7730,7 +7766,7 @@
       </p:pic>
       <p:pic>
         <p:nvPicPr>
-          <p:cNvPr id="8" name="Imagen 7" descr="Diagrama&#10;&#10;El contenido generado por IA puede ser incorrecto.">
+          <p:cNvPr id="8" name="Imagen 7" descr="Diagrama UML aplicado del patrón Command">
             <a:extLst>
               <a:ext uri="{FF2B5EF4-FFF2-40B4-BE49-F238E27FC236}">
                 <a16:creationId xmlns:a16="http://schemas.microsoft.com/office/drawing/2014/main" id="{BD38A06B-26EF-17D3-AC7C-2FDE94A5D3F6}"/>
@@ -7750,8 +7786,8 @@
         </p:blipFill>
         <p:spPr>
           <a:xfrm>
-            <a:off x="4100000" y="935963"/>
-            <a:ext cx="7900000" cy="5449227"/>
+            <a:off x="5902527" y="950000"/>
+            <a:ext cx="6039473" cy="5550000"/>
           </a:xfrm>
           <a:prstGeom prst="rect">
             <a:avLst/>
@@ -7794,7 +7830,7 @@
                   <a:srgbClr val="2F5496"/>
                 </a:solidFill>
               </a:rPr>
-              <a:t>UML del ejemplo: control de luces</a:t>
+              <a:t>UML del ejemplo: control domótico</a:t>
             </a:r>
             <a:endParaRPr lang="en-US" sz="2800" dirty="0"/>
           </a:p>
@@ -7832,7 +7868,7 @@
       </p:grpSpPr>
       <p:pic>
         <p:nvPicPr>
-          <p:cNvPr id="3" name="Imagen 2" descr="Texto&#10;&#10;El contenido generado por IA puede ser incorrecto.">
+          <p:cNvPr id="3" name="Imagen 2" descr="Salida de consola de MainCommandControlLuces">
             <a:extLst>
               <a:ext uri="{FF2B5EF4-FFF2-40B4-BE49-F238E27FC236}">
                 <a16:creationId xmlns:a16="http://schemas.microsoft.com/office/drawing/2014/main" id="{DE810DC8-3DC8-D51E-65C4-88DF4F5D1360}"/>
@@ -7852,8 +7888,8 @@
         </p:blipFill>
         <p:spPr>
           <a:xfrm>
-            <a:off x="2150190" y="2233360"/>
-            <a:ext cx="7891619" cy="2871075"/>
+            <a:off x="2819101" y="1050000"/>
+            <a:ext cx="6553797" cy="5450000"/>
           </a:xfrm>
           <a:prstGeom prst="rect">
             <a:avLst/>
@@ -8313,7 +8349,7 @@
                   <a:schemeClr val="accent2"/>
                 </a:solidFill>
               </a:rPr>
-              <a:t>Uso crítico de inteligencia artificial</a:t>
+              <a:t>Uso crítico de IA (1/2): diseño inicial</a:t>
             </a:r>
             <a:endParaRPr lang="en-US" sz="2800" dirty="0">
               <a:solidFill>
@@ -8845,7 +8881,7 @@
                   <a:srgbClr val="272727"/>
                 </a:solidFill>
               </a:rPr>
-              <a:t>• Puede soportar deshacer/rehacer si guarda el estado necesario.</a:t>
+              <a:t>• Soporta deshacer: historial en el control y una pila de estados por comando.</a:t>
             </a:r>
             <a:endParaRPr lang="en-US" sz="1250" dirty="0"/>
           </a:p>
@@ -9026,7 +9062,7 @@
                   <a:srgbClr val="272727"/>
                 </a:solidFill>
               </a:rPr>
-              <a:t>• Deshacer exige controlar el estado previo.</a:t>
+              <a:t>• Deshacer supone que nadie cambia el dispositivo por fuera del control.</a:t>
             </a:r>
             <a:endParaRPr lang="en-US" sz="1250" dirty="0"/>
           </a:p>
@@ -10318,7 +10354,7 @@
                             <a:srgbClr val="272727"/>
                           </a:solidFill>
                         </a:rPr>
-                        <a:t>Ejemplo</a:t>
+                        <a:t>Ejemplo implementado</a:t>
                       </a:r>
                       <a:endParaRPr lang="en-US" sz="1500" dirty="0"/>
                     </a:p>
@@ -10379,7 +10415,7 @@
                             <a:srgbClr val="272727"/>
                           </a:solidFill>
                         </a:rPr>
-                        <a:t>Torre de control</a:t>
+                        <a:t>Torre de control con prioridad sanitaria</a:t>
                       </a:r>
                       <a:endParaRPr lang="en-US" sz="1500" dirty="0"/>
                     </a:p>
@@ -10440,7 +10476,7 @@
                             <a:srgbClr val="272727"/>
                           </a:solidFill>
                         </a:rPr>
-                        <a:t>Control remoto</a:t>
+                        <a:t>Control domótico con deshacer y escenas</a:t>
                       </a:r>
                       <a:endParaRPr lang="en-US" sz="1500" dirty="0"/>
                     </a:p>
@@ -11856,158 +11892,6 @@
       </p:sp>
       <p:sp>
         <p:nvSpPr>
-          <p:cNvPr id="5" name="Text 2"/>
-          <p:cNvSpPr/>
-          <p:nvPr/>
-        </p:nvSpPr>
-        <p:spPr>
-          <a:xfrm>
-            <a:off x="868680" y="1234440"/>
-            <a:ext cx="10424160" cy="566928"/>
-          </a:xfrm>
-          <a:prstGeom prst="rect">
-            <a:avLst/>
-          </a:prstGeom>
-          <a:noFill/>
-          <a:ln/>
-        </p:spPr>
-        <p:txBody>
-          <a:bodyPr wrap="square" lIns="254" tIns="254" rIns="254" bIns="254" rtlCol="0" anchor="ctr">
-            <a:normAutofit/>
-          </a:bodyPr>
-          <a:lstStyle/>
-          <a:p>
-            <a:pPr marL="0" indent="0">
-              <a:buNone/>
-            </a:pPr>
-            <a:r>
-              <a:rPr lang="en-US" sz="1500" dirty="0">
-                <a:solidFill>
-                  <a:srgbClr val="272727"/>
-                </a:solidFill>
-              </a:rPr>
-              <a:t>Gamma, E., Helm, R., Johnson, R., &amp; Vlissides, J. (1994). Design patterns: Elements of reusable object-oriented software. Addison-Wesley.</a:t>
-            </a:r>
-            <a:endParaRPr lang="en-US" sz="1500" dirty="0"/>
-          </a:p>
-        </p:txBody>
-      </p:sp>
-      <p:sp>
-        <p:nvSpPr>
-          <p:cNvPr id="6" name="Text 3"/>
-          <p:cNvSpPr/>
-          <p:nvPr/>
-        </p:nvSpPr>
-        <p:spPr>
-          <a:xfrm>
-            <a:off x="868680" y="2075688"/>
-            <a:ext cx="10424160" cy="566928"/>
-          </a:xfrm>
-          <a:prstGeom prst="rect">
-            <a:avLst/>
-          </a:prstGeom>
-          <a:noFill/>
-          <a:ln/>
-        </p:spPr>
-        <p:txBody>
-          <a:bodyPr wrap="square" lIns="254" tIns="254" rIns="254" bIns="254" rtlCol="0" anchor="ctr">
-            <a:normAutofit/>
-          </a:bodyPr>
-          <a:lstStyle/>
-          <a:p>
-            <a:pPr marL="0" indent="0">
-              <a:buNone/>
-            </a:pPr>
-            <a:r>
-              <a:rPr lang="en-US" sz="1500" dirty="0">
-                <a:solidFill>
-                  <a:srgbClr val="272727"/>
-                </a:solidFill>
-              </a:rPr>
-              <a:t>Refactoring.Guru. (s. f.). Mediator. https://refactoring.guru/es/design-patterns/mediator</a:t>
-            </a:r>
-            <a:endParaRPr lang="en-US" sz="1500" dirty="0"/>
-          </a:p>
-        </p:txBody>
-      </p:sp>
-      <p:sp>
-        <p:nvSpPr>
-          <p:cNvPr id="7" name="Text 4"/>
-          <p:cNvSpPr/>
-          <p:nvPr/>
-        </p:nvSpPr>
-        <p:spPr>
-          <a:xfrm>
-            <a:off x="868680" y="2916936"/>
-            <a:ext cx="10424160" cy="566928"/>
-          </a:xfrm>
-          <a:prstGeom prst="rect">
-            <a:avLst/>
-          </a:prstGeom>
-          <a:noFill/>
-          <a:ln/>
-        </p:spPr>
-        <p:txBody>
-          <a:bodyPr wrap="square" lIns="254" tIns="254" rIns="254" bIns="254" rtlCol="0" anchor="ctr">
-            <a:normAutofit/>
-          </a:bodyPr>
-          <a:lstStyle/>
-          <a:p>
-            <a:pPr marL="0" indent="0">
-              <a:buNone/>
-            </a:pPr>
-            <a:r>
-              <a:rPr lang="en-US" sz="1500" dirty="0">
-                <a:solidFill>
-                  <a:srgbClr val="272727"/>
-                </a:solidFill>
-              </a:rPr>
-              <a:t>Refactoring.Guru. (s. f.). Command. https://refactoring.guru/es/design-patterns/command</a:t>
-            </a:r>
-            <a:endParaRPr lang="en-US" sz="1500" dirty="0"/>
-          </a:p>
-        </p:txBody>
-      </p:sp>
-      <p:sp>
-        <p:nvSpPr>
-          <p:cNvPr id="9" name="Text 6"/>
-          <p:cNvSpPr/>
-          <p:nvPr/>
-        </p:nvSpPr>
-        <p:spPr>
-          <a:xfrm>
-            <a:off x="880252" y="3639312"/>
-            <a:ext cx="10424160" cy="566928"/>
-          </a:xfrm>
-          <a:prstGeom prst="rect">
-            <a:avLst/>
-          </a:prstGeom>
-          <a:noFill/>
-          <a:ln/>
-        </p:spPr>
-        <p:txBody>
-          <a:bodyPr wrap="square" lIns="254" tIns="254" rIns="254" bIns="254" rtlCol="0" anchor="ctr">
-            <a:normAutofit/>
-          </a:bodyPr>
-          <a:lstStyle/>
-          <a:p>
-            <a:pPr marL="0" indent="0">
-              <a:buNone/>
-            </a:pPr>
-            <a:r>
-              <a:rPr lang="en-US" sz="1500" dirty="0">
-                <a:solidFill>
-                  <a:srgbClr val="272727"/>
-                </a:solidFill>
-              </a:rPr>
-              <a:t>Oracle. (s. f.). Java documentation. https://docs.oracle.com/en/java/</a:t>
-            </a:r>
-            <a:endParaRPr lang="en-US" sz="1500" dirty="0"/>
-          </a:p>
-        </p:txBody>
-      </p:sp>
-      <p:sp>
-        <p:nvSpPr>
           <p:cNvPr id="10" name="Shape 7"/>
           <p:cNvSpPr/>
           <p:nvPr/>
@@ -12125,7 +12009,985 @@
           </a:p>
         </p:txBody>
       </p:sp>
+      <p:sp>
+        <p:nvSpPr>
+          <p:cNvPr id="910" name="Referencia 1"/>
+          <p:cNvSpPr/>
+          <p:nvPr/>
+        </p:nvSpPr>
+        <p:spPr>
+          <a:xfrm>
+            <a:off x="868680" y="1200000"/>
+            <a:ext cx="10424160" cy="566928"/>
+          </a:xfrm>
+          <a:prstGeom prst="rect">
+            <a:avLst/>
+          </a:prstGeom>
+          <a:noFill/>
+          <a:ln/>
+        </p:spPr>
+        <p:txBody>
+          <a:bodyPr wrap="square" lIns="254" tIns="254" rIns="254" bIns="254" rtlCol="0" anchor="ctr">
+            <a:normAutofit/>
+          </a:bodyPr>
+          <a:lstStyle/>
+          <a:p>
+            <a:pPr marL="0" indent="0">
+              <a:buNone/>
+            </a:pPr>
+            <a:r>
+              <a:rPr lang="en-US" sz="1500" dirty="0">
+                <a:solidFill>
+                  <a:srgbClr val="272727"/>
+                </a:solidFill>
+              </a:rPr>
+              <a:t>Fowler, M. (2004). UML distilled: A brief guide to the standard object modeling language (3.ª ed.). Addison-Wesley.</a:t>
+            </a:r>
+            <a:endParaRPr lang="en-US" sz="1500" dirty="0"/>
+          </a:p>
+        </p:txBody>
+      </p:sp>
+      <p:sp>
+        <p:nvSpPr>
+          <p:cNvPr id="911" name="Referencia 2"/>
+          <p:cNvSpPr/>
+          <p:nvPr/>
+        </p:nvSpPr>
+        <p:spPr>
+          <a:xfrm>
+            <a:off x="868680" y="1820000"/>
+            <a:ext cx="10424160" cy="566928"/>
+          </a:xfrm>
+          <a:prstGeom prst="rect">
+            <a:avLst/>
+          </a:prstGeom>
+          <a:noFill/>
+          <a:ln/>
+        </p:spPr>
+        <p:txBody>
+          <a:bodyPr wrap="square" lIns="254" tIns="254" rIns="254" bIns="254" rtlCol="0" anchor="ctr">
+            <a:normAutofit/>
+          </a:bodyPr>
+          <a:lstStyle/>
+          <a:p>
+            <a:pPr marL="0" indent="0">
+              <a:buNone/>
+            </a:pPr>
+            <a:r>
+              <a:rPr lang="en-US" sz="1500" dirty="0">
+                <a:solidFill>
+                  <a:srgbClr val="272727"/>
+                </a:solidFill>
+              </a:rPr>
+              <a:t>Freeman, E., y Robson, E. (2020). Head First design patterns (2.ª ed.). O’Reilly Media.</a:t>
+            </a:r>
+            <a:endParaRPr lang="en-US" sz="1500" dirty="0"/>
+          </a:p>
+        </p:txBody>
+      </p:sp>
+      <p:sp>
+        <p:nvSpPr>
+          <p:cNvPr id="912" name="Referencia 3"/>
+          <p:cNvSpPr/>
+          <p:nvPr/>
+        </p:nvSpPr>
+        <p:spPr>
+          <a:xfrm>
+            <a:off x="868680" y="2440000"/>
+            <a:ext cx="10424160" cy="566928"/>
+          </a:xfrm>
+          <a:prstGeom prst="rect">
+            <a:avLst/>
+          </a:prstGeom>
+          <a:noFill/>
+          <a:ln/>
+        </p:spPr>
+        <p:txBody>
+          <a:bodyPr wrap="square" lIns="254" tIns="254" rIns="254" bIns="254" rtlCol="0" anchor="ctr">
+            <a:normAutofit/>
+          </a:bodyPr>
+          <a:lstStyle/>
+          <a:p>
+            <a:pPr marL="0" indent="0">
+              <a:buNone/>
+            </a:pPr>
+            <a:r>
+              <a:rPr lang="en-US" sz="1500" dirty="0">
+                <a:solidFill>
+                  <a:srgbClr val="272727"/>
+                </a:solidFill>
+              </a:rPr>
+              <a:t>Gamma, E., Helm, R., Johnson, R., y Vlissides, J. (1994). Design patterns: Elements of reusable object-oriented software. Addison-Wesley.</a:t>
+            </a:r>
+            <a:endParaRPr lang="en-US" sz="1500" dirty="0"/>
+          </a:p>
+        </p:txBody>
+      </p:sp>
+      <p:sp>
+        <p:nvSpPr>
+          <p:cNvPr id="913" name="Referencia 4"/>
+          <p:cNvSpPr/>
+          <p:nvPr/>
+        </p:nvSpPr>
+        <p:spPr>
+          <a:xfrm>
+            <a:off x="868680" y="3060000"/>
+            <a:ext cx="10424160" cy="566928"/>
+          </a:xfrm>
+          <a:prstGeom prst="rect">
+            <a:avLst/>
+          </a:prstGeom>
+          <a:noFill/>
+          <a:ln/>
+        </p:spPr>
+        <p:txBody>
+          <a:bodyPr wrap="square" lIns="254" tIns="254" rIns="254" bIns="254" rtlCol="0" anchor="ctr">
+            <a:normAutofit/>
+          </a:bodyPr>
+          <a:lstStyle/>
+          <a:p>
+            <a:pPr marL="0" indent="0">
+              <a:buNone/>
+            </a:pPr>
+            <a:r>
+              <a:rPr lang="en-US" sz="1500" dirty="0">
+                <a:solidFill>
+                  <a:srgbClr val="272727"/>
+                </a:solidFill>
+              </a:rPr>
+              <a:t>JUnit Team. (s. f.). JUnit 5 user guide. https://junit.org/junit5/docs/current/user-guide/</a:t>
+            </a:r>
+            <a:endParaRPr lang="en-US" sz="1500" dirty="0"/>
+          </a:p>
+        </p:txBody>
+      </p:sp>
+      <p:sp>
+        <p:nvSpPr>
+          <p:cNvPr id="914" name="Referencia 5"/>
+          <p:cNvSpPr/>
+          <p:nvPr/>
+        </p:nvSpPr>
+        <p:spPr>
+          <a:xfrm>
+            <a:off x="868680" y="3680000"/>
+            <a:ext cx="10424160" cy="566928"/>
+          </a:xfrm>
+          <a:prstGeom prst="rect">
+            <a:avLst/>
+          </a:prstGeom>
+          <a:noFill/>
+          <a:ln/>
+        </p:spPr>
+        <p:txBody>
+          <a:bodyPr wrap="square" lIns="254" tIns="254" rIns="254" bIns="254" rtlCol="0" anchor="ctr">
+            <a:normAutofit/>
+          </a:bodyPr>
+          <a:lstStyle/>
+          <a:p>
+            <a:pPr marL="0" indent="0">
+              <a:buNone/>
+            </a:pPr>
+            <a:r>
+              <a:rPr lang="en-US" sz="1500" dirty="0">
+                <a:solidFill>
+                  <a:srgbClr val="272727"/>
+                </a:solidFill>
+              </a:rPr>
+              <a:t>Oracle. (s. f.). Java documentation. https://docs.oracle.com/en/java/</a:t>
+            </a:r>
+            <a:endParaRPr lang="en-US" sz="1500" dirty="0"/>
+          </a:p>
+        </p:txBody>
+      </p:sp>
+      <p:sp>
+        <p:nvSpPr>
+          <p:cNvPr id="915" name="Referencia 6"/>
+          <p:cNvSpPr/>
+          <p:nvPr/>
+        </p:nvSpPr>
+        <p:spPr>
+          <a:xfrm>
+            <a:off x="868680" y="4300000"/>
+            <a:ext cx="10424160" cy="566928"/>
+          </a:xfrm>
+          <a:prstGeom prst="rect">
+            <a:avLst/>
+          </a:prstGeom>
+          <a:noFill/>
+          <a:ln/>
+        </p:spPr>
+        <p:txBody>
+          <a:bodyPr wrap="square" lIns="254" tIns="254" rIns="254" bIns="254" rtlCol="0" anchor="ctr">
+            <a:normAutofit/>
+          </a:bodyPr>
+          <a:lstStyle/>
+          <a:p>
+            <a:pPr marL="0" indent="0">
+              <a:buNone/>
+            </a:pPr>
+            <a:r>
+              <a:rPr lang="en-US" sz="1500" dirty="0">
+                <a:solidFill>
+                  <a:srgbClr val="272727"/>
+                </a:solidFill>
+              </a:rPr>
+              <a:t>Refactoring.Guru. (s. f.-a). Command. https://refactoring.guru/es/design-patterns/command</a:t>
+            </a:r>
+            <a:endParaRPr lang="en-US" sz="1500" dirty="0"/>
+          </a:p>
+        </p:txBody>
+      </p:sp>
+      <p:sp>
+        <p:nvSpPr>
+          <p:cNvPr id="916" name="Referencia 7"/>
+          <p:cNvSpPr/>
+          <p:nvPr/>
+        </p:nvSpPr>
+        <p:spPr>
+          <a:xfrm>
+            <a:off x="868680" y="4920000"/>
+            <a:ext cx="10424160" cy="566928"/>
+          </a:xfrm>
+          <a:prstGeom prst="rect">
+            <a:avLst/>
+          </a:prstGeom>
+          <a:noFill/>
+          <a:ln/>
+        </p:spPr>
+        <p:txBody>
+          <a:bodyPr wrap="square" lIns="254" tIns="254" rIns="254" bIns="254" rtlCol="0" anchor="ctr">
+            <a:normAutofit/>
+          </a:bodyPr>
+          <a:lstStyle/>
+          <a:p>
+            <a:pPr marL="0" indent="0">
+              <a:buNone/>
+            </a:pPr>
+            <a:r>
+              <a:rPr lang="en-US" sz="1500" dirty="0">
+                <a:solidFill>
+                  <a:srgbClr val="272727"/>
+                </a:solidFill>
+              </a:rPr>
+              <a:t>Refactoring.Guru. (s. f.-b). Mediator. https://refactoring.guru/es/design-patterns/mediator</a:t>
+            </a:r>
+            <a:endParaRPr lang="en-US" sz="1500" dirty="0"/>
+          </a:p>
+        </p:txBody>
+      </p:sp>
     </p:spTree>
+  </p:cSld>
+  <p:clrMapOvr>
+    <a:masterClrMapping/>
+  </p:clrMapOvr>
+</p:sld>
+</file>
+
+<file path=ppt/slides/slide23.xml><?xml version="1.0" encoding="utf-8"?>
+<p:sld xmlns:a="http://schemas.openxmlformats.org/drawingml/2006/main" xmlns:r="http://schemas.openxmlformats.org/officeDocument/2006/relationships" xmlns:p="http://schemas.openxmlformats.org/presentationml/2006/main">
+  <p:cSld>
+    <p:spTree>
+      <p:nvGrpSpPr>
+        <p:cNvPr id="1" name=""/>
+        <p:cNvGrpSpPr/>
+        <p:nvPr/>
+      </p:nvGrpSpPr>
+      <p:grpSpPr>
+        <a:xfrm>
+          <a:off x="0" y="0"/>
+          <a:ext cx="0" cy="0"/>
+          <a:chOff x="0" y="0"/>
+          <a:chExt cx="0" cy="0"/>
+        </a:xfrm>
+      </p:grpSpPr>
+      <p:sp>
+        <p:nvSpPr>
+          <p:cNvPr id="5" name="Shape 2">
+            <a:extLst>
+              <a:ext uri="{FF2B5EF4-FFF2-40B4-BE49-F238E27FC236}">
+                <a16:creationId xmlns:a16="http://schemas.microsoft.com/office/drawing/2014/main" id="{F7945D11-CA90-7FB9-7C97-DCC35564BF6C}"/>
+              </a:ext>
+            </a:extLst>
+          </p:cNvPr>
+          <p:cNvSpPr/>
+          <p:nvPr/>
+        </p:nvSpPr>
+        <p:spPr>
+          <a:xfrm>
+            <a:off x="640080" y="1170432"/>
+            <a:ext cx="10899648" cy="4848402"/>
+          </a:xfrm>
+          <a:prstGeom prst="roundRect">
+            <a:avLst>
+              <a:gd name="adj" fmla="val 4000"/>
+            </a:avLst>
+          </a:prstGeom>
+          <a:solidFill>
+            <a:srgbClr val="FFFFFF"/>
+          </a:solidFill>
+          <a:ln w="12700">
+            <a:solidFill>
+              <a:srgbClr val="D7E0E8"/>
+            </a:solidFill>
+            <a:prstDash val="solid"/>
+          </a:ln>
+          <a:effectLst/>
+        </p:spPr>
+        <p:txBody>
+          <a:bodyPr/>
+          <a:lstStyle/>
+          <a:p>
+            <a:r>
+              <a:rPr lang="es-MX" sz="1500" b="1" dirty="0">
+                <a:solidFill>
+                  <a:schemeClr val="accent2"/>
+                </a:solidFill>
+              </a:rPr>
+              <a:t>Prompt de revisión:</a:t>
+            </a:r>
+          </a:p>
+          <a:p>
+            <a:r>
+              <a:rPr lang="es-MX" sz="1500" dirty="0">
+                <a:solidFill>
+                  <a:schemeClr val="accent1">
+                    <a:lumMod val="75000"/>
+                  </a:schemeClr>
+                </a:solidFill>
+              </a:rPr>
+              <a:t>"Revisa el documento guía de la actividad y lo desarrollado en nuestra resolución (código, UML e informe) y dinos qué se puede mejorar para obtener la calificación más alta."</a:t>
+            </a:r>
+          </a:p>
+          <a:p>
+            <a:endParaRPr lang="es-MX" sz="900" dirty="0">
+              <a:solidFill>
+                <a:schemeClr val="accent1">
+                  <a:lumMod val="75000"/>
+                </a:schemeClr>
+              </a:solidFill>
+            </a:endParaRPr>
+          </a:p>
+          <a:p>
+            <a:r>
+              <a:rPr lang="es-MX" sz="1500" b="1" dirty="0">
+                <a:solidFill>
+                  <a:schemeClr val="accent2"/>
+                </a:solidFill>
+              </a:rPr>
+              <a:t>Recomendación aceptada (con justificación):</a:t>
+            </a:r>
+          </a:p>
+          <a:p>
+            <a:r>
+              <a:rPr lang="es-MX" sz="1500" b="1" dirty="0">
+                <a:solidFill>
+                  <a:schemeClr val="accent2"/>
+                </a:solidFill>
+              </a:rPr>
+              <a:t>Sugerencia:</a:t>
+            </a:r>
+            <a:r>
+              <a:rPr lang="es-MX" sz="1500" dirty="0">
+                <a:solidFill>
+                  <a:schemeClr val="accent1">
+                    <a:lumMod val="75000"/>
+                  </a:schemeClr>
+                </a:solidFill>
+              </a:rPr>
+              <a:t> el informe afirmaba que agregar aeronaves no afecta a las demás, pero el código tenía un solo tipo de colega. La IA propuso incorporar un segundo colega con una regla propia.</a:t>
+            </a:r>
+          </a:p>
+          <a:p>
+            <a:r>
+              <a:rPr lang="es-MX" sz="1500" b="1" dirty="0">
+                <a:solidFill>
+                  <a:schemeClr val="accent2"/>
+                </a:solidFill>
+              </a:rPr>
+              <a:t>Justificación:</a:t>
+            </a:r>
+            <a:r>
+              <a:rPr lang="es-MX" sz="1500" dirty="0">
+                <a:solidFill>
+                  <a:schemeClr val="accent1">
+                    <a:lumMod val="75000"/>
+                  </a:schemeClr>
+                </a:solidFill>
+              </a:rPr>
+              <a:t> se agregó AvionSanitario con prioridad. La extensión solo modificó la torre y quedó cubierta por pruebas. También se separaron las asociaciones del UML y el registro de aeronaves pasó al cliente.</a:t>
+            </a:r>
+          </a:p>
+          <a:p>
+            <a:endParaRPr lang="es-MX" sz="900" dirty="0">
+              <a:solidFill>
+                <a:schemeClr val="accent1">
+                  <a:lumMod val="75000"/>
+                </a:schemeClr>
+              </a:solidFill>
+            </a:endParaRPr>
+          </a:p>
+          <a:p>
+            <a:r>
+              <a:rPr lang="es-MX" sz="1500" b="1" dirty="0">
+                <a:solidFill>
+                  <a:schemeClr val="accent2"/>
+                </a:solidFill>
+              </a:rPr>
+              <a:t>Recomendación rechazada (con justificación):</a:t>
+            </a:r>
+          </a:p>
+          <a:p>
+            <a:r>
+              <a:rPr lang="es-MX" sz="1500" b="1" dirty="0">
+                <a:solidFill>
+                  <a:schemeClr val="accent2"/>
+                </a:solidFill>
+              </a:rPr>
+              <a:t>Sugerencia de la IA:</a:t>
+            </a:r>
+            <a:r>
+              <a:rPr lang="es-MX" sz="1500" dirty="0">
+                <a:solidFill>
+                  <a:schemeClr val="accent1">
+                    <a:lumMod val="75000"/>
+                  </a:schemeClr>
+                </a:solidFill>
+              </a:rPr>
+              <a:t> crear un segundo mediador, TorreControlConPrioridad, para la nueva regla.</a:t>
+            </a:r>
+          </a:p>
+          <a:p>
+            <a:r>
+              <a:rPr lang="es-MX" sz="1500" b="1" dirty="0">
+                <a:solidFill>
+                  <a:schemeClr val="accent2"/>
+                </a:solidFill>
+              </a:rPr>
+              <a:t>Justificación:</a:t>
+            </a:r>
+            <a:r>
+              <a:rPr lang="es-MX" sz="1500" dirty="0">
+                <a:solidFill>
+                  <a:schemeClr val="accent1">
+                    <a:lumMod val="75000"/>
+                  </a:schemeClr>
+                </a:solidFill>
+              </a:rPr>
+              <a:t> duplicaba toda la gestión de colas para cambiar una sola regla. Cada aeronave declara esPrioritaria() y la torre usa ese dato, sin recurrir a instanceof y con un único mediador.</a:t>
+            </a:r>
+          </a:p>
+        </p:txBody>
+      </p:sp>
+      <p:sp>
+        <p:nvSpPr>
+          <p:cNvPr id="8" name="Text 1">
+            <a:extLst>
+              <a:ext uri="{FF2B5EF4-FFF2-40B4-BE49-F238E27FC236}">
+                <a16:creationId xmlns:a16="http://schemas.microsoft.com/office/drawing/2014/main" id="{19DA606D-BD5D-9EBA-2AD3-6D0887782349}"/>
+              </a:ext>
+            </a:extLst>
+          </p:cNvPr>
+          <p:cNvSpPr/>
+          <p:nvPr/>
+        </p:nvSpPr>
+        <p:spPr>
+          <a:xfrm>
+            <a:off x="566928" y="476179"/>
+            <a:ext cx="10972800" cy="566928"/>
+          </a:xfrm>
+          <a:prstGeom prst="rect">
+            <a:avLst/>
+          </a:prstGeom>
+          <a:noFill/>
+          <a:ln/>
+        </p:spPr>
+        <p:txBody>
+          <a:bodyPr wrap="square" lIns="0" tIns="0" rIns="0" bIns="0" rtlCol="0" anchor="ctr"/>
+          <a:lstStyle/>
+          <a:p>
+            <a:pPr marL="0" indent="0">
+              <a:buNone/>
+            </a:pPr>
+            <a:r>
+              <a:rPr lang="en-US" sz="2800" b="1" dirty="0">
+                <a:solidFill>
+                  <a:schemeClr val="accent2"/>
+                </a:solidFill>
+              </a:rPr>
+              <a:t>Uso crítico de IA (2/2): revisión del trabajo</a:t>
+            </a:r>
+            <a:endParaRPr lang="en-US" sz="2800" dirty="0">
+              <a:solidFill>
+                <a:schemeClr val="accent2"/>
+              </a:solidFill>
+            </a:endParaRPr>
+          </a:p>
+        </p:txBody>
+      </p:sp>
+    </p:spTree>
+    <p:extLst>
+      <p:ext uri="{BB962C8B-B14F-4D97-AF65-F5344CB8AC3E}">
+        <p14:creationId xmlns:p14="http://schemas.microsoft.com/office/powerpoint/2010/main" val="1955147137"/>
+      </p:ext>
+    </p:extLst>
+  </p:cSld>
+  <p:clrMapOvr>
+    <a:masterClrMapping/>
+  </p:clrMapOvr>
+</p:sld>
+</file>
+
+<file path=ppt/slides/slide24.xml><?xml version="1.0" encoding="utf-8"?>
+<p:sld xmlns:a="http://schemas.openxmlformats.org/drawingml/2006/main" xmlns:r="http://schemas.openxmlformats.org/officeDocument/2006/relationships" xmlns:p="http://schemas.openxmlformats.org/presentationml/2006/main">
+  <p:cSld>
+    <p:spTree>
+      <p:nvGrpSpPr>
+        <p:cNvPr id="1" name="">
+          <a:extLst>
+            <a:ext uri="{FF2B5EF4-FFF2-40B4-BE49-F238E27FC236}">
+              <a16:creationId xmlns:a16="http://schemas.microsoft.com/office/drawing/2014/main" id="{3BF87744-B111-59EF-96E1-D6614966FD3A}"/>
+            </a:ext>
+          </a:extLst>
+        </p:cNvPr>
+        <p:cNvGrpSpPr/>
+        <p:nvPr/>
+      </p:nvGrpSpPr>
+      <p:grpSpPr>
+        <a:xfrm>
+          <a:off x="0" y="0"/>
+          <a:ext cx="0" cy="0"/>
+          <a:chOff x="0" y="0"/>
+          <a:chExt cx="0" cy="0"/>
+        </a:xfrm>
+      </p:grpSpPr>
+      <p:sp>
+        <p:nvSpPr>
+          <p:cNvPr id="5" name="Shape 2">
+            <a:extLst>
+              <a:ext uri="{FF2B5EF4-FFF2-40B4-BE49-F238E27FC236}">
+                <a16:creationId xmlns:a16="http://schemas.microsoft.com/office/drawing/2014/main" id="{A2E01925-8FA4-5436-7F0D-1F1B95B84ADB}"/>
+              </a:ext>
+            </a:extLst>
+          </p:cNvPr>
+          <p:cNvSpPr/>
+          <p:nvPr/>
+        </p:nvSpPr>
+        <p:spPr>
+          <a:xfrm>
+            <a:off x="640080" y="1170432"/>
+            <a:ext cx="10899648" cy="4848402"/>
+          </a:xfrm>
+          <a:prstGeom prst="roundRect">
+            <a:avLst>
+              <a:gd name="adj" fmla="val 4000"/>
+            </a:avLst>
+          </a:prstGeom>
+          <a:solidFill>
+            <a:srgbClr val="FFFFFF"/>
+          </a:solidFill>
+          <a:ln w="12700">
+            <a:solidFill>
+              <a:srgbClr val="D7E0E8"/>
+            </a:solidFill>
+            <a:prstDash val="solid"/>
+          </a:ln>
+          <a:effectLst/>
+        </p:spPr>
+        <p:txBody>
+          <a:bodyPr/>
+          <a:lstStyle/>
+          <a:p>
+            <a:r>
+              <a:rPr lang="es-MX" sz="1500" b="1" dirty="0">
+                <a:solidFill>
+                  <a:schemeClr val="accent2"/>
+                </a:solidFill>
+              </a:rPr>
+              <a:t>Prompt de revisión:</a:t>
+            </a:r>
+          </a:p>
+          <a:p>
+            <a:r>
+              <a:rPr lang="es-MX" sz="1500" dirty="0">
+                <a:solidFill>
+                  <a:schemeClr val="accent1">
+                    <a:lumMod val="75000"/>
+                  </a:schemeClr>
+                </a:solidFill>
+              </a:rPr>
+              <a:t>"Revisa el documento guía de la actividad y lo desarrollado en nuestra resolución (código, UML e informe) y dinos qué se puede mejorar para obtener la calificación más alta."</a:t>
+            </a:r>
+          </a:p>
+          <a:p>
+            <a:endParaRPr lang="es-MX" sz="900" dirty="0">
+              <a:solidFill>
+                <a:schemeClr val="accent1">
+                  <a:lumMod val="75000"/>
+                </a:schemeClr>
+              </a:solidFill>
+            </a:endParaRPr>
+          </a:p>
+          <a:p>
+            <a:r>
+              <a:rPr lang="es-MX" sz="1500" b="1" dirty="0">
+                <a:solidFill>
+                  <a:schemeClr val="accent2"/>
+                </a:solidFill>
+              </a:rPr>
+              <a:t>Recomendación aceptada (con justificación):</a:t>
+            </a:r>
+          </a:p>
+          <a:p>
+            <a:r>
+              <a:rPr lang="es-MX" sz="1500" b="1" dirty="0">
+                <a:solidFill>
+                  <a:schemeClr val="accent2"/>
+                </a:solidFill>
+              </a:rPr>
+              <a:t>Sugerencia:</a:t>
+            </a:r>
+            <a:r>
+              <a:rPr lang="es-MX" sz="1500" dirty="0">
+                <a:solidFill>
+                  <a:schemeClr val="accent1">
+                    <a:lumMod val="75000"/>
+                  </a:schemeClr>
+                </a:solidFill>
+              </a:rPr>
+              <a:t> el escenario inicial (un botón, una luz, encender y apagar) no aprovechaba lo que distingue a Command de Strategy. La IA propuso agregar deshacer, un segundo dispositivo y escenas.</a:t>
+            </a:r>
+          </a:p>
+          <a:p>
+            <a:r>
+              <a:rPr lang="es-MX" sz="1500" b="1" dirty="0">
+                <a:solidFill>
+                  <a:schemeClr val="accent2"/>
+                </a:solidFill>
+              </a:rPr>
+              <a:t>Justificación:</a:t>
+            </a:r>
+            <a:r>
+              <a:rPr lang="es-MX" sz="1500" dirty="0">
+                <a:solidFill>
+                  <a:schemeClr val="accent1">
+                    <a:lumMod val="75000"/>
+                  </a:schemeClr>
+                </a:solidFill>
+              </a:rPr>
+              <a:t> se implementaron deshacer() con historial, Ventilador y MacroComando. Cada uno ejercita una consecuencia distinta del patrón y ControlRemoto sigue sin condicionales ni referencias a dispositivos.</a:t>
+            </a:r>
+          </a:p>
+          <a:p>
+            <a:endParaRPr lang="es-MX" sz="900" dirty="0">
+              <a:solidFill>
+                <a:schemeClr val="accent1">
+                  <a:lumMod val="75000"/>
+                </a:schemeClr>
+              </a:solidFill>
+            </a:endParaRPr>
+          </a:p>
+          <a:p>
+            <a:r>
+              <a:rPr lang="es-MX" sz="1500" b="1" dirty="0">
+                <a:solidFill>
+                  <a:schemeClr val="accent2"/>
+                </a:solidFill>
+              </a:rPr>
+              <a:t>Recomendación modificada (con justificación):</a:t>
+            </a:r>
+          </a:p>
+          <a:p>
+            <a:r>
+              <a:rPr lang="es-MX" sz="1500" b="1" dirty="0">
+                <a:solidFill>
+                  <a:schemeClr val="accent2"/>
+                </a:solidFill>
+              </a:rPr>
+              <a:t>Sugerencia de la IA:</a:t>
+            </a:r>
+            <a:r>
+              <a:rPr lang="es-MX" sz="1500" dirty="0">
+                <a:solidFill>
+                  <a:schemeClr val="accent1">
+                    <a:lumMod val="75000"/>
+                  </a:schemeClr>
+                </a:solidFill>
+              </a:rPr>
+              <a:t> guardar el estado anterior del dispositivo en un campo de cada comando para poder deshacer.</a:t>
+            </a:r>
+          </a:p>
+          <a:p>
+            <a:r>
+              <a:rPr lang="es-MX" sz="1500" b="1" dirty="0">
+                <a:solidFill>
+                  <a:schemeClr val="accent2"/>
+                </a:solidFill>
+              </a:rPr>
+              <a:t>Justificación:</a:t>
+            </a:r>
+            <a:r>
+              <a:rPr lang="es-MX" sz="1500" dirty="0">
+                <a:solidFill>
+                  <a:schemeClr val="accent1">
+                    <a:lumMod val="75000"/>
+                  </a:schemeClr>
+                </a:solidFill>
+              </a:rPr>
+              <a:t> se cambió a una pila por comando: si el mismo comando se ejecuta dos veces, un único campo se sobrescribe y el segundo deshacer deja el dispositivo en un estado incorrecto. Una prueba unitaria cubre ese caso.</a:t>
+            </a:r>
+          </a:p>
+        </p:txBody>
+      </p:sp>
+      <p:sp>
+        <p:nvSpPr>
+          <p:cNvPr id="8" name="Text 1">
+            <a:extLst>
+              <a:ext uri="{FF2B5EF4-FFF2-40B4-BE49-F238E27FC236}">
+                <a16:creationId xmlns:a16="http://schemas.microsoft.com/office/drawing/2014/main" id="{9797F45B-6E01-ADE9-6472-A8EF3F338D78}"/>
+              </a:ext>
+            </a:extLst>
+          </p:cNvPr>
+          <p:cNvSpPr/>
+          <p:nvPr/>
+        </p:nvSpPr>
+        <p:spPr>
+          <a:xfrm>
+            <a:off x="566928" y="476179"/>
+            <a:ext cx="10972800" cy="566928"/>
+          </a:xfrm>
+          <a:prstGeom prst="rect">
+            <a:avLst/>
+          </a:prstGeom>
+          <a:noFill/>
+          <a:ln/>
+        </p:spPr>
+        <p:txBody>
+          <a:bodyPr wrap="square" lIns="0" tIns="0" rIns="0" bIns="0" rtlCol="0" anchor="ctr"/>
+          <a:lstStyle/>
+          <a:p>
+            <a:pPr marL="0" indent="0">
+              <a:buNone/>
+            </a:pPr>
+            <a:r>
+              <a:rPr lang="en-US" sz="2800" b="1" dirty="0">
+                <a:solidFill>
+                  <a:schemeClr val="accent2"/>
+                </a:solidFill>
+              </a:rPr>
+              <a:t>Uso crítico de IA (2/2): revisión del trabajo</a:t>
+            </a:r>
+            <a:endParaRPr lang="en-US" sz="2800" dirty="0">
+              <a:solidFill>
+                <a:schemeClr val="accent2"/>
+              </a:solidFill>
+            </a:endParaRPr>
+          </a:p>
+        </p:txBody>
+      </p:sp>
+    </p:spTree>
+    <p:extLst>
+      <p:ext uri="{BB962C8B-B14F-4D97-AF65-F5344CB8AC3E}">
+        <p14:creationId xmlns:p14="http://schemas.microsoft.com/office/powerpoint/2010/main" val="4145045421"/>
+      </p:ext>
+    </p:extLst>
+  </p:cSld>
+  <p:clrMapOvr>
+    <a:masterClrMapping/>
+  </p:clrMapOvr>
+</p:sld>
+</file>
+
+<file path=ppt/slides/slide25.xml><?xml version="1.0" encoding="utf-8"?>
+<p:sld xmlns:a="http://schemas.openxmlformats.org/drawingml/2006/main" xmlns:r="http://schemas.openxmlformats.org/officeDocument/2006/relationships" xmlns:p="http://schemas.openxmlformats.org/presentationml/2006/main">
+  <p:cSld>
+    <p:spTree>
+      <p:nvGrpSpPr>
+        <p:cNvPr id="1" name=""/>
+        <p:cNvGrpSpPr/>
+        <p:nvPr/>
+      </p:nvGrpSpPr>
+      <p:grpSpPr>
+        <a:xfrm>
+          <a:off x="0" y="0"/>
+          <a:ext cx="0" cy="0"/>
+          <a:chOff x="0" y="0"/>
+          <a:chExt cx="0" cy="0"/>
+        </a:xfrm>
+      </p:grpSpPr>
+      <p:pic>
+        <p:nvPicPr>
+          <p:cNvPr id="3" name="Imagen 2" descr="Resultado de mvn test: 13 pruebas, 0 fallos">
+            <a:extLst>
+              <a:ext uri="{FF2B5EF4-FFF2-40B4-BE49-F238E27FC236}">
+                <a16:creationId xmlns:a16="http://schemas.microsoft.com/office/drawing/2014/main" id="{DE810DC8-3DC8-D51E-65C4-88DF4F5D1360}"/>
+              </a:ext>
+            </a:extLst>
+          </p:cNvPr>
+          <p:cNvPicPr>
+            <a:picLocks noChangeAspect="1"/>
+          </p:cNvPicPr>
+          <p:nvPr/>
+        </p:nvPicPr>
+        <p:blipFill>
+          <a:blip r:embed="rId2"/>
+          <a:stretch>
+            <a:fillRect/>
+          </a:stretch>
+        </p:blipFill>
+        <p:spPr>
+          <a:xfrm>
+            <a:off x="846000" y="1250000"/>
+            <a:ext cx="10500000" cy="2496226"/>
+          </a:xfrm>
+          <a:prstGeom prst="rect">
+            <a:avLst/>
+          </a:prstGeom>
+        </p:spPr>
+      </p:pic>
+      <p:sp>
+        <p:nvSpPr>
+          <p:cNvPr id="5" name="Text 1">
+            <a:extLst>
+              <a:ext uri="{FF2B5EF4-FFF2-40B4-BE49-F238E27FC236}">
+                <a16:creationId xmlns:a16="http://schemas.microsoft.com/office/drawing/2014/main" id="{A422619D-EEFB-AFAA-F9F8-03A3E0810D87}"/>
+              </a:ext>
+            </a:extLst>
+          </p:cNvPr>
+          <p:cNvSpPr/>
+          <p:nvPr/>
+        </p:nvSpPr>
+        <p:spPr>
+          <a:xfrm>
+            <a:off x="312517" y="451530"/>
+            <a:ext cx="10972800" cy="566928"/>
+          </a:xfrm>
+          <a:prstGeom prst="rect">
+            <a:avLst/>
+          </a:prstGeom>
+          <a:noFill/>
+          <a:ln/>
+        </p:spPr>
+        <p:txBody>
+          <a:bodyPr wrap="square" lIns="0" tIns="0" rIns="0" bIns="0" rtlCol="0" anchor="ctr"/>
+          <a:lstStyle/>
+          <a:p>
+            <a:pPr marL="0" indent="0">
+              <a:buNone/>
+            </a:pPr>
+            <a:r>
+              <a:rPr lang="es-MX" sz="2800" b="1" dirty="0">
+                <a:solidFill>
+                  <a:srgbClr val="2F5496"/>
+                </a:solidFill>
+              </a:rPr>
+              <a:t>Pruebas automatizadas (JUnit 5)</a:t>
+            </a:r>
+            <a:endParaRPr lang="en-US" sz="2800" dirty="0"/>
+          </a:p>
+        </p:txBody>
+      </p:sp>
+      <p:sp>
+        <p:nvSpPr>
+          <p:cNvPr id="901" name="Resumen de pruebas"/>
+          <p:cNvSpPr txBox="1"/>
+          <p:nvPr/>
+        </p:nvSpPr>
+        <p:spPr>
+          <a:xfrm>
+            <a:off x="846000" y="4096226"/>
+            <a:ext cx="10500000" cy="2000000"/>
+          </a:xfrm>
+          <a:prstGeom prst="rect">
+            <a:avLst/>
+          </a:prstGeom>
+          <a:noFill/>
+        </p:spPr>
+        <p:txBody>
+          <a:bodyPr wrap="square" lIns="0" tIns="0" rIns="0" bIns="0" anchor="t"/>
+          <a:lstStyle/>
+          <a:p>
+            <a:pPr>
+              <a:spcAft>
+                <a:spcPts val="900"/>
+              </a:spcAft>
+            </a:pPr>
+            <a:r>
+              <a:rPr lang="es-MX" sz="1500" b="1" dirty="0">
+                <a:solidFill>
+                  <a:schemeClr val="accent2"/>
+                </a:solidFill>
+              </a:rPr>
+              <a:t>Mediator (6 pruebas): </a:t>
+            </a:r>
+            <a:r>
+              <a:rPr lang="es-MX" sz="1500" dirty="0">
+                <a:solidFill>
+                  <a:schemeClr val="accent1">
+                    <a:lumMod val="75000"/>
+                  </a:schemeClr>
+                </a:solidFill>
+              </a:rPr>
+              <a:t>orden de llegada, prioridad del vuelo sanitario, solicitudes duplicadas o de aeronaves no registradas, y ningún aterrizaje sin autorización.</a:t>
+            </a:r>
+          </a:p>
+          <a:p>
+            <a:pPr>
+              <a:spcAft>
+                <a:spcPts val="900"/>
+              </a:spcAft>
+            </a:pPr>
+            <a:r>
+              <a:rPr lang="es-MX" sz="1500" b="1" dirty="0">
+                <a:solidFill>
+                  <a:schemeClr val="accent2"/>
+                </a:solidFill>
+              </a:rPr>
+              <a:t>Command (7 pruebas): </a:t>
+            </a:r>
+            <a:r>
+              <a:rPr lang="es-MX" sz="1500" dirty="0">
+                <a:solidFill>
+                  <a:schemeClr val="accent1">
+                    <a:lumMod val="75000"/>
+                  </a:schemeClr>
+                </a:solidFill>
+              </a:rPr>
+              <a:t>ejecución por botón, reasignación en ejecución, deshacer de cada comando (incluido el mismo comando ejecutado dos veces), macro como una sola acción y botones inexistentes.</a:t>
+            </a:r>
+          </a:p>
+          <a:p>
+            <a:pPr>
+              <a:spcAft>
+                <a:spcPts val="900"/>
+              </a:spcAft>
+            </a:pPr>
+            <a:r>
+              <a:rPr lang="es-MX" sz="1500" b="1" dirty="0">
+                <a:solidFill>
+                  <a:schemeClr val="accent2"/>
+                </a:solidFill>
+              </a:rPr>
+              <a:t>Ejecución: </a:t>
+            </a:r>
+            <a:r>
+              <a:rPr lang="es-MX" sz="1500" dirty="0">
+                <a:solidFill>
+                  <a:schemeClr val="accent1">
+                    <a:lumMod val="75000"/>
+                  </a:schemeClr>
+                </a:solidFill>
+              </a:rPr>
+              <a:t>mvn test desde codigo/ejercicios. Resultado: 13 pruebas, 0 fallos.</a:t>
+            </a:r>
+          </a:p>
+        </p:txBody>
+      </p:sp>
+    </p:spTree>
+    <p:extLst>
+      <p:ext uri="{BB962C8B-B14F-4D97-AF65-F5344CB8AC3E}">
+        <p14:creationId xmlns:p14="http://schemas.microsoft.com/office/powerpoint/2010/main" val="1902299845"/>
+      </p:ext>
+    </p:extLst>
   </p:cSld>
   <p:clrMapOvr>
     <a:masterClrMapping/>
@@ -15185,7 +16047,7 @@
                   <a:srgbClr val="272727"/>
                 </a:solidFill>
               </a:rPr>
-              <a:t>→ AvionComercial</a:t>
+              <a:t>→ AvionComercial, AvionSanitario</a:t>
             </a:r>
             <a:endParaRPr lang="en-US" sz="1400" dirty="0"/>
           </a:p>
@@ -15353,7 +16215,7 @@
                   </a:schemeClr>
                 </a:solidFill>
               </a:rPr>
-              <a:t>"En un sistema de gestión de tráfico aéreo, múltiples aeronaves necesitan coordinar el aterrizaje sobre una misma pista. Si cada aeronave estableciera comunicación directa y bilateral con las demás, se generaría una red caótica de dependencias cruzadas (muchos a muchos), provocando un alto acoplamiento, rigidez estructural y una alta complejidad para gestionar el estado compartido de la pista y el orden de espera. Se requiere un diseño que centralice la coordinación en una torre de control que autorice y notifique a las aeronaves, permitiendo que estas interactúen de manera completamente desacoplada."</a:t>
+              <a:t>"En un aeródromo con una sola pista, varias aeronaves deben coordinar su aterrizaje: los vuelos comerciales se atienden por orden de llegada y los sanitarios tienen prioridad sobre los regulares en espera. Si cada aeronave se comunicara directamente con las demás, se generaría una red de dependencias cruzadas (hasta n·(n−1)), la regla de turnos quedaría repartida entre todas las clases y agregar la prioridad sanitaria obligaría a modificar cada tipo de aeronave. Se requiere un diseño que centralice en una torre de control el estado de la pista, las colas y la regla de prioridad, de modo que las aeronaves solo se comuniquen con ella."</a:t>
             </a:r>
             <a:endParaRPr lang="en-US" dirty="0">
               <a:solidFill>
@@ -15762,7 +16624,7 @@
             </a:pPr>
             <a:r>
               <a:rPr lang="en-US" sz="1050" dirty="0"/>
-              <a:t>- listaAeronaves  - colaEspera  - aeronaveEnPista</a:t>
+              <a:t>- listaAeronaves  - colaPrioritaria  - colaEspera  - aeronaveEnPista</a:t>
             </a:r>
           </a:p>
         </p:txBody>
@@ -15892,7 +16754,7 @@
             </a:pPr>
             <a:r>
               <a:rPr lang="en-US" sz="1050" dirty="0"/>
-              <a:t># identificador  # torreControl  # autorizada</a:t>
+              <a:t># identificador  # autorizada  + esPrioritaria()</a:t>
             </a:r>
           </a:p>
         </p:txBody>
@@ -15988,7 +16850,7 @@
             </a:pPr>
             <a:r>
               <a:rPr lang="en-US" sz="1600" b="1" dirty="0"/>
-              <a:t>AvionComercial</a:t>
+              <a:t>AvionComercial · AvionSanitario</a:t>
             </a:r>
             <a:endParaRPr lang="en-US" sz="1600" dirty="0"/>
           </a:p>
@@ -16022,7 +16884,7 @@
             </a:pPr>
             <a:r>
               <a:rPr lang="en-US" sz="1050" dirty="0"/>
-              <a:t>solicita y recibe autorización</a:t>
+              <a:t>esPrioritaria(): false · true</a:t>
             </a:r>
           </a:p>
         </p:txBody>
@@ -16286,7 +17148,7 @@
                   <a:srgbClr val="272727"/>
                 </a:solidFill>
               </a:rPr>
-              <a:t>• La torre concreta administra la pista y la cola de espera, y notifica a las aeronaves.</a:t>
+              <a:t>• La torre concreta administra la pista, la cola prioritaria y la regular, y notifica a las aeronaves.</a:t>
             </a:r>
             <a:endParaRPr lang="en-US" sz="1250" dirty="0"/>
           </a:p>
@@ -16306,7 +17168,7 @@
                   <a:srgbClr val="272727"/>
                 </a:solidFill>
               </a:rPr>
-              <a:t>• AvionComercial especializa a Aeronave.</a:t>
+              <a:t>• AvionComercial y AvionSanitario especializan a Aeronave; esPrioritaria() define la cola.</a:t>
             </a:r>
             <a:endParaRPr lang="en-US" sz="1250" dirty="0"/>
           </a:p>
@@ -16346,7 +17208,7 @@
                   <a:srgbClr val="272727"/>
                 </a:solidFill>
               </a:rPr>
-              <a:t>• MainMediatorTorreControl crea la torre y las aeronaves.</a:t>
+              <a:t>• MainMediatorTorreControl crea la torre y registra las aeronaves.</a:t>
             </a:r>
             <a:endParaRPr lang="en-US" sz="1250" dirty="0"/>
           </a:p>
@@ -16610,7 +17472,7 @@
       </p:grpSpPr>
       <p:pic>
         <p:nvPicPr>
-          <p:cNvPr id="5" name="Imagen 4" descr="Diagrama&#10;&#10;El contenido generado por IA puede ser incorrecto.">
+          <p:cNvPr id="5" name="Imagen 4" descr="Diagrama original sin Mediator">
             <a:extLst>
               <a:ext uri="{FF2B5EF4-FFF2-40B4-BE49-F238E27FC236}">
                 <a16:creationId xmlns:a16="http://schemas.microsoft.com/office/drawing/2014/main" id="{6715E2DD-F00C-A344-4D42-67913B81F3BC}"/>
@@ -16647,7 +17509,7 @@
       </p:pic>
       <p:pic>
         <p:nvPicPr>
-          <p:cNvPr id="7" name="Imagen 6" descr="Diagrama&#10;&#10;El contenido generado por IA puede ser incorrecto.">
+          <p:cNvPr id="7" name="Imagen 6" descr="Diagrama UML aplicado del patrón Mediator">
             <a:extLst>
               <a:ext uri="{FF2B5EF4-FFF2-40B4-BE49-F238E27FC236}">
                 <a16:creationId xmlns:a16="http://schemas.microsoft.com/office/drawing/2014/main" id="{97253BB4-055D-38AE-09DC-E8498744A81F}"/>
@@ -16667,8 +17529,8 @@
         </p:blipFill>
         <p:spPr>
           <a:xfrm>
-            <a:off x="4568815" y="1000000"/>
-            <a:ext cx="7062369" cy="5250000"/>
+            <a:off x="4500000" y="1000000"/>
+            <a:ext cx="7300000" cy="4472279"/>
           </a:xfrm>
           <a:prstGeom prst="rect">
             <a:avLst/>
@@ -16755,7 +17617,7 @@
       </p:grpSpPr>
       <p:pic>
         <p:nvPicPr>
-          <p:cNvPr id="3" name="Imagen 2" descr="Texto&#10;&#10;El contenido generado por IA puede ser incorrecto.">
+          <p:cNvPr id="3" name="Imagen 2" descr="Salida de consola de MainMediatorTorreControl">
             <a:extLst>
               <a:ext uri="{FF2B5EF4-FFF2-40B4-BE49-F238E27FC236}">
                 <a16:creationId xmlns:a16="http://schemas.microsoft.com/office/drawing/2014/main" id="{F749CC16-2D30-41A1-3962-FA1D07A4B5C3}"/>
@@ -16775,8 +17637,8 @@
         </p:blipFill>
         <p:spPr>
           <a:xfrm>
-            <a:off x="1325000" y="950000"/>
-            <a:ext cx="9542000" cy="5500000"/>
+            <a:off x="2890118" y="1000000"/>
+            <a:ext cx="6411764" cy="5450000"/>
           </a:xfrm>
           <a:prstGeom prst="rect">
             <a:avLst/>

</xml_diff>